<commit_message>
Actualizar presentación Introduccion al espacio de estados
</commit_message>
<xml_diff>
--- a/Semana_2_Clasificacion_de_sistemas/Introduccion al espacio de estados.pptx
+++ b/Semana_2_Clasificacion_de_sistemas/Introduccion al espacio de estados.pptx
@@ -167,6 +167,43 @@
 </p:presentation>
 </file>
 
+<file path=ppt/changesInfos/changesInfo1.xml><?xml version="1.0" encoding="utf-8"?>
+<pc:chgInfo xmlns:a="http://schemas.openxmlformats.org/drawingml/2006/main" xmlns:r="http://schemas.openxmlformats.org/officeDocument/2006/relationships" xmlns:ac="http://schemas.microsoft.com/office/drawing/2013/main/command" xmlns:pc="http://schemas.microsoft.com/office/powerpoint/2013/main/command">
+  <pc:docChgLst>
+    <pc:chgData name="JHEYSON FABIAN VILLAVISAN BUITRAGO" userId="e5ced5c2-d787-455d-b115-4f08a699b8c8" providerId="ADAL" clId="{6F85ADF9-4154-43EC-8FCF-2B8E9588BEA1}"/>
+    <pc:docChg chg="modSld">
+      <pc:chgData name="JHEYSON FABIAN VILLAVISAN BUITRAGO" userId="e5ced5c2-d787-455d-b115-4f08a699b8c8" providerId="ADAL" clId="{6F85ADF9-4154-43EC-8FCF-2B8E9588BEA1}" dt="2026-08-19T12:47:05.916" v="6" actId="1076"/>
+      <pc:docMkLst>
+        <pc:docMk/>
+      </pc:docMkLst>
+      <pc:sldChg chg="addSp modSp mod">
+        <pc:chgData name="JHEYSON FABIAN VILLAVISAN BUITRAGO" userId="e5ced5c2-d787-455d-b115-4f08a699b8c8" providerId="ADAL" clId="{6F85ADF9-4154-43EC-8FCF-2B8E9588BEA1}" dt="2026-08-19T12:47:05.916" v="6" actId="1076"/>
+        <pc:sldMkLst>
+          <pc:docMk/>
+          <pc:sldMk cId="0" sldId="261"/>
+        </pc:sldMkLst>
+        <pc:spChg chg="mod">
+          <ac:chgData name="JHEYSON FABIAN VILLAVISAN BUITRAGO" userId="e5ced5c2-d787-455d-b115-4f08a699b8c8" providerId="ADAL" clId="{6F85ADF9-4154-43EC-8FCF-2B8E9588BEA1}" dt="2026-08-19T12:47:02.948" v="5" actId="14100"/>
+          <ac:spMkLst>
+            <pc:docMk/>
+            <pc:sldMk cId="0" sldId="261"/>
+            <ac:spMk id="15" creationId="{00000000-0000-0000-0000-000000000000}"/>
+          </ac:spMkLst>
+        </pc:spChg>
+        <pc:picChg chg="add mod">
+          <ac:chgData name="JHEYSON FABIAN VILLAVISAN BUITRAGO" userId="e5ced5c2-d787-455d-b115-4f08a699b8c8" providerId="ADAL" clId="{6F85ADF9-4154-43EC-8FCF-2B8E9588BEA1}" dt="2026-08-19T12:47:05.916" v="6" actId="1076"/>
+          <ac:picMkLst>
+            <pc:docMk/>
+            <pc:sldMk cId="0" sldId="261"/>
+            <ac:picMk id="17" creationId="{39DD5C5A-F7CF-A01C-6064-A7B92814CBE2}"/>
+          </ac:picMkLst>
+        </pc:picChg>
+      </pc:sldChg>
+    </pc:docChg>
+  </pc:docChgLst>
+</pc:chgInfo>
+</file>
+
 <file path=ppt/slideLayouts/slideLayout1.xml><?xml version="1.0" encoding="utf-8"?>
 <p:sldLayout xmlns:a="http://schemas.openxmlformats.org/drawingml/2006/main" xmlns:r="http://schemas.openxmlformats.org/officeDocument/2006/relationships" xmlns:p="http://schemas.openxmlformats.org/presentationml/2006/main" type="title" preserve="1">
   <p:cSld name="Title Slide">
@@ -346,7 +383,7 @@
           <a:p>
             <a:fld id="{5BCAD085-E8A6-8845-BD4E-CB4CCA059FC4}" type="datetimeFigureOut">
               <a:rPr lang="en-US" smtClean="0"/>
-              <a:t>8/8/26</a:t>
+              <a:t>8/19/2026</a:t>
             </a:fld>
             <a:endParaRPr lang="en-US"/>
           </a:p>
@@ -514,7 +551,7 @@
           <a:p>
             <a:fld id="{5BCAD085-E8A6-8845-BD4E-CB4CCA059FC4}" type="datetimeFigureOut">
               <a:rPr lang="en-US" smtClean="0"/>
-              <a:t>8/8/26</a:t>
+              <a:t>8/19/2026</a:t>
             </a:fld>
             <a:endParaRPr lang="en-US"/>
           </a:p>
@@ -692,7 +729,7 @@
           <a:p>
             <a:fld id="{5BCAD085-E8A6-8845-BD4E-CB4CCA059FC4}" type="datetimeFigureOut">
               <a:rPr lang="en-US" smtClean="0"/>
-              <a:t>8/8/26</a:t>
+              <a:t>8/19/2026</a:t>
             </a:fld>
             <a:endParaRPr lang="en-US"/>
           </a:p>
@@ -860,7 +897,7 @@
           <a:p>
             <a:fld id="{5BCAD085-E8A6-8845-BD4E-CB4CCA059FC4}" type="datetimeFigureOut">
               <a:rPr lang="en-US" smtClean="0"/>
-              <a:t>8/8/26</a:t>
+              <a:t>8/19/2026</a:t>
             </a:fld>
             <a:endParaRPr lang="en-US"/>
           </a:p>
@@ -1105,7 +1142,7 @@
           <a:p>
             <a:fld id="{5BCAD085-E8A6-8845-BD4E-CB4CCA059FC4}" type="datetimeFigureOut">
               <a:rPr lang="en-US" smtClean="0"/>
-              <a:t>8/8/26</a:t>
+              <a:t>8/19/2026</a:t>
             </a:fld>
             <a:endParaRPr lang="en-US"/>
           </a:p>
@@ -1390,7 +1427,7 @@
           <a:p>
             <a:fld id="{5BCAD085-E8A6-8845-BD4E-CB4CCA059FC4}" type="datetimeFigureOut">
               <a:rPr lang="en-US" smtClean="0"/>
-              <a:t>8/8/26</a:t>
+              <a:t>8/19/2026</a:t>
             </a:fld>
             <a:endParaRPr lang="en-US"/>
           </a:p>
@@ -1809,7 +1846,7 @@
           <a:p>
             <a:fld id="{5BCAD085-E8A6-8845-BD4E-CB4CCA059FC4}" type="datetimeFigureOut">
               <a:rPr lang="en-US" smtClean="0"/>
-              <a:t>8/8/26</a:t>
+              <a:t>8/19/2026</a:t>
             </a:fld>
             <a:endParaRPr lang="en-US"/>
           </a:p>
@@ -1926,7 +1963,7 @@
           <a:p>
             <a:fld id="{5BCAD085-E8A6-8845-BD4E-CB4CCA059FC4}" type="datetimeFigureOut">
               <a:rPr lang="en-US" smtClean="0"/>
-              <a:t>8/8/26</a:t>
+              <a:t>8/19/2026</a:t>
             </a:fld>
             <a:endParaRPr lang="en-US"/>
           </a:p>
@@ -2021,7 +2058,7 @@
           <a:p>
             <a:fld id="{5BCAD085-E8A6-8845-BD4E-CB4CCA059FC4}" type="datetimeFigureOut">
               <a:rPr lang="en-US" smtClean="0"/>
-              <a:t>8/8/26</a:t>
+              <a:t>8/19/2026</a:t>
             </a:fld>
             <a:endParaRPr lang="en-US"/>
           </a:p>
@@ -2296,7 +2333,7 @@
           <a:p>
             <a:fld id="{5BCAD085-E8A6-8845-BD4E-CB4CCA059FC4}" type="datetimeFigureOut">
               <a:rPr lang="en-US" smtClean="0"/>
-              <a:t>8/8/26</a:t>
+              <a:t>8/19/2026</a:t>
             </a:fld>
             <a:endParaRPr lang="en-US"/>
           </a:p>
@@ -2548,7 +2585,7 @@
           <a:p>
             <a:fld id="{5BCAD085-E8A6-8845-BD4E-CB4CCA059FC4}" type="datetimeFigureOut">
               <a:rPr lang="en-US" smtClean="0"/>
-              <a:t>8/8/26</a:t>
+              <a:t>8/19/2026</a:t>
             </a:fld>
             <a:endParaRPr lang="en-US"/>
           </a:p>
@@ -2759,7 +2796,7 @@
           <a:p>
             <a:fld id="{5BCAD085-E8A6-8845-BD4E-CB4CCA059FC4}" type="datetimeFigureOut">
               <a:rPr lang="en-US" smtClean="0"/>
-              <a:t>8/8/26</a:t>
+              <a:t>8/19/2026</a:t>
             </a:fld>
             <a:endParaRPr lang="en-US"/>
           </a:p>
@@ -22816,7 +22853,7 @@
                         </a:spcAft>
                       </a:pPr>
                       <a:r>
-                        <a:rPr sz="1532" b="0">
+                        <a:rPr sz="1532" b="0" dirty="0">
                           <a:solidFill>
                             <a:srgbClr val="000000"/>
                           </a:solidFill>
@@ -23026,14 +23063,65 @@
                         </a:spcAft>
                       </a:pPr>
                       <a:r>
-                        <a:rPr sz="1532" b="0">
+                        <a:rPr sz="1532" b="0" dirty="0">
                           <a:solidFill>
                             <a:srgbClr val="000000"/>
                           </a:solidFill>
                           <a:latin typeface="Arial"/>
                         </a:rPr>
-                        <a:t>Variables internas que no se miden</a:t>
+                        <a:t>Variables </a:t>
                       </a:r>
+                      <a:r>
+                        <a:rPr sz="1532" b="0" dirty="0" err="1">
+                          <a:solidFill>
+                            <a:srgbClr val="000000"/>
+                          </a:solidFill>
+                          <a:latin typeface="Arial"/>
+                        </a:rPr>
+                        <a:t>internas</a:t>
+                      </a:r>
+                      <a:r>
+                        <a:rPr sz="1532" b="0" dirty="0">
+                          <a:solidFill>
+                            <a:srgbClr val="000000"/>
+                          </a:solidFill>
+                          <a:latin typeface="Arial"/>
+                        </a:rPr>
+                        <a:t> </a:t>
+                      </a:r>
+                      <a:r>
+                        <a:rPr sz="1532" b="0" dirty="0" err="1">
+                          <a:solidFill>
+                            <a:srgbClr val="000000"/>
+                          </a:solidFill>
+                          <a:latin typeface="Arial"/>
+                        </a:rPr>
+                        <a:t>que</a:t>
+                      </a:r>
+                      <a:r>
+                        <a:rPr sz="1532" b="0" dirty="0">
+                          <a:solidFill>
+                            <a:srgbClr val="000000"/>
+                          </a:solidFill>
+                          <a:latin typeface="Arial"/>
+                        </a:rPr>
+                        <a:t> no se </a:t>
+                      </a:r>
+                      <a:r>
+                        <a:rPr sz="1532" b="0" dirty="0" err="1">
+                          <a:solidFill>
+                            <a:srgbClr val="000000"/>
+                          </a:solidFill>
+                          <a:latin typeface="Arial"/>
+                        </a:rPr>
+                        <a:t>miden</a:t>
+                      </a:r>
+                      <a:endParaRPr sz="1532" b="0" dirty="0">
+                        <a:solidFill>
+                          <a:srgbClr val="000000"/>
+                        </a:solidFill>
+                        <a:latin typeface="Arial"/>
+                      </a:endParaRPr>
                     </a:p>
                   </a:txBody>
                   <a:tcPr anchor="ctr">
@@ -28099,7 +28187,7 @@
         <p:spPr>
           <a:xfrm>
             <a:off x="658368" y="5044846"/>
-            <a:ext cx="10872216" cy="527507"/>
+            <a:ext cx="5844032" cy="849463"/>
           </a:xfrm>
           <a:prstGeom prst="rect">
             <a:avLst/>
@@ -28121,17 +28209,263 @@
               </a:spcAft>
             </a:pPr>
             <a:r>
-              <a:rPr sz="1760" b="0">
-                <a:solidFill>
-                  <a:srgbClr val="000000"/>
-                </a:solidFill>
-                <a:latin typeface="Arial"/>
-              </a:rPr>
-              <a:t>Los dos modelos describen la misma planta, pero el segundo también responde qué pasa si la masa arranca desplazada y con velocidad.</a:t>
-            </a:r>
-          </a:p>
-        </p:txBody>
-      </p:sp>
+              <a:rPr sz="1760" b="0" dirty="0">
+                <a:solidFill>
+                  <a:srgbClr val="000000"/>
+                </a:solidFill>
+                <a:latin typeface="Arial"/>
+              </a:rPr>
+              <a:t>Los dos </a:t>
+            </a:r>
+            <a:r>
+              <a:rPr sz="1760" b="0" dirty="0" err="1">
+                <a:solidFill>
+                  <a:srgbClr val="000000"/>
+                </a:solidFill>
+                <a:latin typeface="Arial"/>
+              </a:rPr>
+              <a:t>modelos</a:t>
+            </a:r>
+            <a:r>
+              <a:rPr sz="1760" b="0" dirty="0">
+                <a:solidFill>
+                  <a:srgbClr val="000000"/>
+                </a:solidFill>
+                <a:latin typeface="Arial"/>
+              </a:rPr>
+              <a:t> </a:t>
+            </a:r>
+            <a:r>
+              <a:rPr sz="1760" b="0" dirty="0" err="1">
+                <a:solidFill>
+                  <a:srgbClr val="000000"/>
+                </a:solidFill>
+                <a:latin typeface="Arial"/>
+              </a:rPr>
+              <a:t>describen</a:t>
+            </a:r>
+            <a:r>
+              <a:rPr sz="1760" b="0" dirty="0">
+                <a:solidFill>
+                  <a:srgbClr val="000000"/>
+                </a:solidFill>
+                <a:latin typeface="Arial"/>
+              </a:rPr>
+              <a:t> la </a:t>
+            </a:r>
+            <a:r>
+              <a:rPr sz="1760" b="0" dirty="0" err="1">
+                <a:solidFill>
+                  <a:srgbClr val="000000"/>
+                </a:solidFill>
+                <a:latin typeface="Arial"/>
+              </a:rPr>
+              <a:t>misma</a:t>
+            </a:r>
+            <a:r>
+              <a:rPr sz="1760" b="0" dirty="0">
+                <a:solidFill>
+                  <a:srgbClr val="000000"/>
+                </a:solidFill>
+                <a:latin typeface="Arial"/>
+              </a:rPr>
+              <a:t> planta, </a:t>
+            </a:r>
+            <a:r>
+              <a:rPr sz="1760" b="0" dirty="0" err="1">
+                <a:solidFill>
+                  <a:srgbClr val="000000"/>
+                </a:solidFill>
+                <a:latin typeface="Arial"/>
+              </a:rPr>
+              <a:t>pero</a:t>
+            </a:r>
+            <a:r>
+              <a:rPr sz="1760" b="0" dirty="0">
+                <a:solidFill>
+                  <a:srgbClr val="000000"/>
+                </a:solidFill>
+                <a:latin typeface="Arial"/>
+              </a:rPr>
+              <a:t> el </a:t>
+            </a:r>
+            <a:r>
+              <a:rPr sz="1760" b="0" dirty="0" err="1">
+                <a:solidFill>
+                  <a:srgbClr val="000000"/>
+                </a:solidFill>
+                <a:latin typeface="Arial"/>
+              </a:rPr>
+              <a:t>segundo</a:t>
+            </a:r>
+            <a:r>
+              <a:rPr sz="1760" b="0" dirty="0">
+                <a:solidFill>
+                  <a:srgbClr val="000000"/>
+                </a:solidFill>
+                <a:latin typeface="Arial"/>
+              </a:rPr>
+              <a:t> también </a:t>
+            </a:r>
+            <a:r>
+              <a:rPr sz="1760" b="0" dirty="0" err="1">
+                <a:solidFill>
+                  <a:srgbClr val="000000"/>
+                </a:solidFill>
+                <a:latin typeface="Arial"/>
+              </a:rPr>
+              <a:t>responde</a:t>
+            </a:r>
+            <a:r>
+              <a:rPr sz="1760" b="0" dirty="0">
+                <a:solidFill>
+                  <a:srgbClr val="000000"/>
+                </a:solidFill>
+                <a:latin typeface="Arial"/>
+              </a:rPr>
+              <a:t> </a:t>
+            </a:r>
+            <a:r>
+              <a:rPr sz="1760" b="0" dirty="0" err="1">
+                <a:solidFill>
+                  <a:srgbClr val="000000"/>
+                </a:solidFill>
+                <a:latin typeface="Arial"/>
+              </a:rPr>
+              <a:t>qué</a:t>
+            </a:r>
+            <a:r>
+              <a:rPr sz="1760" b="0" dirty="0">
+                <a:solidFill>
+                  <a:srgbClr val="000000"/>
+                </a:solidFill>
+                <a:latin typeface="Arial"/>
+              </a:rPr>
+              <a:t> </a:t>
+            </a:r>
+            <a:r>
+              <a:rPr sz="1760" b="0" dirty="0" err="1">
+                <a:solidFill>
+                  <a:srgbClr val="000000"/>
+                </a:solidFill>
+                <a:latin typeface="Arial"/>
+              </a:rPr>
+              <a:t>pasa</a:t>
+            </a:r>
+            <a:r>
+              <a:rPr sz="1760" b="0" dirty="0">
+                <a:solidFill>
+                  <a:srgbClr val="000000"/>
+                </a:solidFill>
+                <a:latin typeface="Arial"/>
+              </a:rPr>
+              <a:t> </a:t>
+            </a:r>
+            <a:r>
+              <a:rPr sz="1760" b="0" dirty="0" err="1">
+                <a:solidFill>
+                  <a:srgbClr val="000000"/>
+                </a:solidFill>
+                <a:latin typeface="Arial"/>
+              </a:rPr>
+              <a:t>si</a:t>
+            </a:r>
+            <a:r>
+              <a:rPr sz="1760" b="0" dirty="0">
+                <a:solidFill>
+                  <a:srgbClr val="000000"/>
+                </a:solidFill>
+                <a:latin typeface="Arial"/>
+              </a:rPr>
+              <a:t> la masa </a:t>
+            </a:r>
+            <a:r>
+              <a:rPr sz="1760" b="0" dirty="0" err="1">
+                <a:solidFill>
+                  <a:srgbClr val="000000"/>
+                </a:solidFill>
+                <a:latin typeface="Arial"/>
+              </a:rPr>
+              <a:t>arranca</a:t>
+            </a:r>
+            <a:r>
+              <a:rPr sz="1760" b="0" dirty="0">
+                <a:solidFill>
+                  <a:srgbClr val="000000"/>
+                </a:solidFill>
+                <a:latin typeface="Arial"/>
+              </a:rPr>
+              <a:t> </a:t>
+            </a:r>
+            <a:r>
+              <a:rPr sz="1760" b="0" dirty="0" err="1">
+                <a:solidFill>
+                  <a:srgbClr val="000000"/>
+                </a:solidFill>
+                <a:latin typeface="Arial"/>
+              </a:rPr>
+              <a:t>desplazada</a:t>
+            </a:r>
+            <a:r>
+              <a:rPr sz="1760" b="0" dirty="0">
+                <a:solidFill>
+                  <a:srgbClr val="000000"/>
+                </a:solidFill>
+                <a:latin typeface="Arial"/>
+              </a:rPr>
+              <a:t> y con </a:t>
+            </a:r>
+            <a:r>
+              <a:rPr sz="1760" b="0" dirty="0" err="1">
+                <a:solidFill>
+                  <a:srgbClr val="000000"/>
+                </a:solidFill>
+                <a:latin typeface="Arial"/>
+              </a:rPr>
+              <a:t>velocidad</a:t>
+            </a:r>
+            <a:r>
+              <a:rPr sz="1760" b="0" dirty="0">
+                <a:solidFill>
+                  <a:srgbClr val="000000"/>
+                </a:solidFill>
+                <a:latin typeface="Arial"/>
+              </a:rPr>
+              <a:t>.</a:t>
+            </a:r>
+          </a:p>
+        </p:txBody>
+      </p:sp>
+      <p:pic>
+        <p:nvPicPr>
+          <p:cNvPr id="17" name="Imagen 16">
+            <a:extLst>
+              <a:ext uri="{FF2B5EF4-FFF2-40B4-BE49-F238E27FC236}">
+                <a16:creationId xmlns:a16="http://schemas.microsoft.com/office/drawing/2014/main" id="{39DD5C5A-F7CF-A01C-6064-A7B92814CBE2}"/>
+              </a:ext>
+            </a:extLst>
+          </p:cNvPr>
+          <p:cNvPicPr>
+            <a:picLocks noChangeAspect="1"/>
+          </p:cNvPicPr>
+          <p:nvPr/>
+        </p:nvPicPr>
+        <p:blipFill>
+          <a:blip r:embed="rId6"/>
+          <a:stretch>
+            <a:fillRect/>
+          </a:stretch>
+        </p:blipFill>
+        <p:spPr>
+          <a:xfrm>
+            <a:off x="7160768" y="4093959"/>
+            <a:ext cx="4196111" cy="2036348"/>
+          </a:xfrm>
+          <a:prstGeom prst="rect">
+            <a:avLst/>
+          </a:prstGeom>
+        </p:spPr>
+      </p:pic>
     </p:spTree>
   </p:cSld>
   <p:clrMapOvr>

</xml_diff>